<commit_message>
GöAID-Talk: switch deck to English (16 slides, content unchanged)
</commit_message>
<xml_diff>
--- a/presentation/goaid-agentic-ai-in-practice.pptx
+++ b/presentation/goaid-agentic-ai-in-practice.pptx
@@ -518,9 +518,9 @@
             <a:r>
               <a:rPr lang="en-US" dirty="0"/>
               <a:t>notes:
-(1 min) Begrüßung. Satz 1: Ich zeige heute keinen Vortrag ÜBER Agenten,
-sondern einen Betrieb, der VON Agenten gebaut und gefahren wird.
-30 min Inhalt + 10 min Fragen. Sprache: Deutsch, Begriffe Englisch.</a:t>
+(1 min) Welcome. Sentence 1: This is not a talk ABOUT agents — it is
+the story of an operation that is built and run BY agents.
+30 min of content + 10 min of questions.</a:t>
             </a:r>
             <a:endParaRPr lang="en-US" dirty="0"/>
           </a:p>
@@ -609,12 +609,12 @@
             <a:r>
               <a:rPr lang="en-US" dirty="0"/>
               <a:t>notes:
-(3 min) live erzählen, das publikum kennt weiße seiten. Punkt 1:
-Repo/Deploy hingen noch an alten Domains + Platzhalter-IdP-Metadaten.
-Punkt 2: TLS-Terminierung am Ingress vs. ACS-URL-Schema. Der Agent
-brauchte mehrere Probes — aber jede Hypothese war sichtbar. Danach
-wurde die Ursache jeweils zur Probe in der Testsuite. Merksatz:
-"Jeder gefundene Fehler wird ein Test, bevor er wiederkommt."</a:t>
+(3 min) Tell it live; everyone knows white pages. Point 1: repo/deploy
+still hung on old domains + placeholder IdP metadata (by design).
+Point 2: TLS termination at the ingress vs. ACS-URL scheme. The agent
+needed several probes — but every hypothesis was visible. Afterwards
+each root cause became a probe in the test suite. Key line: "Every bug
+found becomes a test before it comes back."</a:t>
             </a:r>
             <a:endParaRPr lang="en-US" dirty="0"/>
           </a:p>
@@ -703,11 +703,11 @@
             <a:r>
               <a:rPr lang="en-US" dirty="0"/>
               <a:t>notes:
-(2 min) Diese Art Arbeit ist langweilig und wichtig — perfekt für
-Agenten. Mensch definiert: was ist "fertig"? (App existiert, Sync
-grün, kein unmanaged Manifest mehr.) Der Agent arbeitet die Liste
-ab. Botschaft an das Publikum:fangen Sie mit so Aufgaben an, nicht
-mit "schreib meine Bewerbung".</a:t>
+(2 min) This kind of work is boring and important — perfect for
+agents. The human defines: what is "done"? (App exists, sync green,
+no unmanaged manifests left.) The agent works through the list.
+Message to the audience: start with tasks like this, not with
+"write my thesis".</a:t>
             </a:r>
             <a:endParaRPr lang="en-US" dirty="0"/>
           </a:p>
@@ -796,10 +796,10 @@
             <a:r>
               <a:rPr lang="en-US" dirty="0"/>
               <a:t>notes:
-(3 min) taskfleet: tasks.json + workers.json, isolierte Worktrees,
-automatischer Merge nur bei grünen Gates. Damit wurden die e2e-Checks
-für alle SSO-Clients gebaut — Logout je Client-Typ, Session-TTL,
-Scopes. Ein Mensch hätte da wochenlang geklickt.</a:t>
+(3 min) taskfleet: tasks.json + workers.json, isolated worktrees,
+automatic merge only with green gates. This is how the e2e checks for
+all SSO clients were built — logout per client type, session TTL,
+scopes. A human would have spent weeks clicking through this.</a:t>
             </a:r>
             <a:endParaRPr lang="en-US" dirty="0"/>
           </a:p>
@@ -888,12 +888,11 @@
             <a:r>
               <a:rPr lang="en-US" dirty="0"/>
               <a:t>notes:
-(2 min) Die drei Lektionen sind bewusst betriebsnah formuliert.
-Token-Fall: Eine enge Spec mit 5 Akzeptanzkriterien schlägt einen
-1000-Zeilen-Prompt. Erwartungen: aus unseren Workshops — Menschen
-wollen "fertige Bots", bekommen ein Werkzeug mit Regeln. Test
-zuerst: die SSO-Suite ist genau so entstanden (59/0/6, jede Warnung
-besprochen).</a:t>
+(2 min) The three lessons are deliberately phrased for operations.
+Token case: a tight spec with 5 acceptance criteria beats a
+1000-line prompt. Expectations: from our workshops — people want
+"finished bots" and get a tool with rules. Test first: the SSO suite
+was built exactly this way (59/0/6, every warning discussed).</a:t>
             </a:r>
             <a:endParaRPr lang="en-US" dirty="0"/>
           </a:p>
@@ -982,10 +981,10 @@
             <a:r>
               <a:rPr lang="en-US" dirty="0"/>
               <a:t>notes:
-(2 min) Die Übertragungs-Folie: das Publikum soll morgen eine Sache
-machen können. Punkt 1 kostet 20 Minuten und verändert alles — der
-Agent liest den Contract bei jedem Start. Punkt 4: experiences /
-Spec-Repo statt Chat-History.</a:t>
+(2 min) The transfer slide: the audience should be able to do one
+thing tomorrow. Point 1 costs 20 minutes and changes everything —
+the agent reads the contract on every start. Point 4: experiences /
+spec repo instead of chat history.</a:t>
             </a:r>
             <a:endParaRPr lang="en-US" dirty="0"/>
           </a:p>
@@ -1074,8 +1073,9 @@
             <a:r>
               <a:rPr lang="en-US" dirty="0"/>
               <a:t>notes:
-(30 s) Nicht vorlesen. Hinweis: der Workshop-Deck (3h-Version) ist
-öffentlich — wer tiefer einsteigen will, macht die Übungen selbst.</a:t>
+(30 s) Do not read aloud. Note: the workshop deck (3h version) is
+public — anyone who wants to go deeper can do the exercises
+themselves.</a:t>
             </a:r>
             <a:endParaRPr lang="en-US" dirty="0"/>
           </a:p>
@@ -1164,10 +1164,10 @@
             <a:r>
               <a:rPr lang="en-US" dirty="0"/>
               <a:t>notes:
-(10 min) Q&amp;A. Wahrscheinliche Fragen: Sicherheit/Rechte der Agenten
-(→ Contract + Plan-Mode + Tests), Modellwahl (→ Harness unabhängig,
-pi läuft mit verschiedenen Providern), Kosten (→ enge Specs, kleine
-Aufträge), Einstieg (→ AGENTS.md + eine langweilige Aufgabe).</a:t>
+(10 min) Q&amp;A. Likely questions: agent permissions/security (→
+contract + plan mode + tests), model choice (→ harness is
+model-agnostic, pi runs with various providers), cost (→ tight specs,
+small orders), getting started (→ AGENTS.md + one boring task).</a:t>
             </a:r>
             <a:endParaRPr lang="en-US" dirty="0"/>
           </a:p>
@@ -1256,11 +1256,11 @@
             <a:r>
               <a:rPr lang="en-US" dirty="0"/>
               <a:t>notes:
-(2 min) Kontext setzen: Uni Marburg, DevOps. Die Suite läuft produktiv
-auf eigenen Bare-Metal-Nodes (SCS-K8s), nicht in einer Public Cloud.
-Zwei Richtungen von "AI-infused": (a) die Suite trägt eigene LLM-/K8s-
-Ressourcen (k8s/llm), (b) der Betrieb selbst wird agentisch gemacht.
-Letzteres ist der Stoff dieses Vortrags.</a:t>
+(2 min) Set the context: University of Marburg, DevOps. The suite runs
+productively on our own bare-metal nodes (SCS-K8s), not in a public
+cloud. Two directions of "AI-infused": (a) the suite carries its own
+LLM/K8s resources (k8s/llm), (b) the operation itself is done
+agentically — the latter is the subject of this talk.</a:t>
             </a:r>
             <a:endParaRPr lang="en-US" dirty="0"/>
           </a:p>
@@ -1349,8 +1349,8 @@
             <a:r>
               <a:rPr lang="en-US" dirty="0"/>
               <a:t>notes:
-(30 s) Nur zeigen, nicht vorlesen. Block 3 ist das Herz — die vier
-Fälle sind echte Incidents/Projekte mit Datum und Ergebnis.</a:t>
+(30 s) Show, don't read. Block 3 is the heart — the four cases are
+real incidents/projects with dates and outcomes.</a:t>
             </a:r>
             <a:endParaRPr lang="en-US" dirty="0"/>
           </a:p>
@@ -1439,11 +1439,10 @@
             <a:r>
               <a:rPr lang="en-US" dirty="0"/>
               <a:t>notes:
-(2 min) Erwartungsmanagement: Agenten sind keine fertigen Bots.
-Ein Modell im Chat-Fenster kann keine Datei anfassen. Der Agent =
-Modell im Rahmen, der ihm Werkzeuge und Regeln gibt.
-Erfahrung aus unseren Kursen (JLU-Feedback): Viele erwarten "fertige
-Bots" — diesen Begriff hier sauber setzen.</a:t>
+(2 min) Expectation management: agents are not finished bots. A model
+in a chat window cannot touch a file. The agent = model inside a frame
+that gives it tools and rules. Lesson from our courses (participant
+feedback): many expect "ready-made bots" — set that term straight here.</a:t>
             </a:r>
             <a:endParaRPr lang="en-US" dirty="0"/>
           </a:p>
@@ -1532,10 +1531,10 @@
             <a:r>
               <a:rPr lang="en-US" dirty="0"/>
               <a:t>notes:
-(2 min) pi kurz zeigen oder beschreiben: öffnet Terminals, liest
-Dateien, führt Git aus, ruft MCP-Tools auf. Plan-Mode = Einwilligung
-vor jeder Änderung. Wichtig fürs Publikum aus dem Betrieb: der Agent
-hat dieselben Rechte wie ich am Arbeitsplatz — deshalb Contract.</a:t>
+(2 min) Briefly show or describe pi: opens terminals, reads files,
+runs git, calls MCP tools. Plan mode = consent before any change.
+Important for the ops crowd: the agent has the same rights I have at
+my workstation — hence the contract.</a:t>
             </a:r>
             <a:endParaRPr lang="en-US" dirty="0"/>
           </a:p>
@@ -1624,9 +1623,9 @@
             <a:r>
               <a:rPr lang="en-US" dirty="0"/>
               <a:t>notes:
-(2 min) Kernfolie der Methode. Die drei Ebenen liegen alle im
-Git-Repo, nicht in Köpfen oder Chats. Überleitung: "Wie kommt man von
-dieser Pyramide zu einem laufenden Workflow? → OpenSpec."</a:t>
+(2 min) Core slide of the method. All three levels live in the git
+repo, not in heads or chats. Transition: "How do you get from this
+pyramid to a running workflow? → OpenSpec."</a:t>
             </a:r>
             <a:endParaRPr lang="en-US" dirty="0"/>
           </a:p>
@@ -1715,10 +1714,10 @@
             <a:r>
               <a:rPr lang="en-US" dirty="0"/>
               <a:t>notes:
-(2 min) OpenSpec-Kommandozeile: new change, continue, apply, archive.
-Der Ablauf: proposal von Mensch oder Agent, Verfeinerung im Dialog,
-dann tasks abarbeiten. Wichtig: "archive" aktualisiert die Specs —
-so bleibt die Doku synchron mit dem System.</a:t>
+(2 min) OpenSpec CLI: new change, continue, apply, archive. The flow:
+proposal by human or agent, refinement in dialogue, then work through
+tasks. Key point: "archive" updates the specs — that is how the docs
+stay in sync with the system.</a:t>
             </a:r>
             <a:endParaRPr lang="en-US" dirty="0"/>
           </a:p>
@@ -1807,11 +1806,10 @@
             <a:r>
               <a:rPr lang="en-US" dirty="0"/>
               <a:t>notes:
-(2 min) Publikum verorten: Wer betreibt sowas ähnliches, kennt die
-Bausteine. Ein Login, acht Dienste. Der untere Bullet ist die
-Kernspannung des Vortrags: Agenten mit Schreibrechten am
-Produktivsystem — wie macht man das verantwortbar? Antwort: die
-nächsten vier Fälle.</a:t>
+(2 min) Locate the audience: anyone running something similar knows
+these components. One login, eight services. The bottom bullet is the
+core tension of this talk: agents with write access on production —
+how do you make that accountable? Answer: the next four cases.</a:t>
             </a:r>
             <a:endParaRPr lang="en-US" dirty="0"/>
           </a:p>
@@ -1900,11 +1898,11 @@
             <a:r>
               <a:rPr lang="en-US" dirty="0"/>
               <a:t>notes:
-(3 min) Der Witz: ohne Spec wäre das eine Woche Handarbeit mit
-Angst. Mit Spec: ein Skript mit eingebauten Guards. Idempotenz ist
-das Abnahmekriterium — zweites Laufen ändert nichts. Story: beim
-ersten Lauf flog die Guard-Prüfung an (ein Verzeichnis zu viel
-gematcht) — genau dafür sind Guards da.</a:t>
+(3 min) The point: without a spec this is a week of manual work and
+fear. With a spec: one script with built-in guards. Idempotency is
+the acceptance criterion — a second run changes nothing. Story: on
+the first run a guard check fired (one directory matched too much) —
+exactly what guards are for.</a:t>
             </a:r>
             <a:endParaRPr lang="en-US" dirty="0"/>
           </a:p>

</xml_diff>

<commit_message>
GöAID-Talk: pi in 60s (install, v1.0, Ctrl+L), pi-sandbox, pi-openspec, agentflow; pyramid slide with 2 concrete examples (20 slides)
</commit_message>
<xml_diff>
--- a/presentation/goaid-agentic-ai-in-practice.pptx
+++ b/presentation/goaid-agentic-ai-in-practice.pptx
@@ -21,9 +21,13 @@
     <p:sldId id="269" r:id="rId15"/>
     <p:sldId id="270" r:id="rId16"/>
     <p:sldId id="271" r:id="rId17"/>
+    <p:sldId id="272" r:id="rId18"/>
+    <p:sldId id="273" r:id="rId19"/>
+    <p:sldId id="274" r:id="rId20"/>
+    <p:sldId id="275" r:id="rId21"/>
   </p:sldIdLst>
   <p:notesMasterIdLst>
-    <p:notesMasterId r:id="rId18"/>
+    <p:notesMasterId r:id="rId22"/>
   </p:notesMasterIdLst>
   <p:sldSz cx="12192000" cy="6858000"/>
   <p:notesSz cx="6858000" cy="12192000"/>
@@ -609,6 +613,284 @@
             <a:r>
               <a:rPr lang="en-US" dirty="0"/>
               <a:t>notes:
+(1.5 min) Closes the loop between method and harness: the Spec→
+Contract workflow is wired directly into pi. Fresh session in a repo
+with openspec/ starts already knowing the change state (auto-injected
+context). /opsx-verify before commit is the habit to copy: validate
++ doctor health sweep. Requires OpenSpec CLI &gt;= 1.9 on PATH.</a:t>
+            </a:r>
+            <a:endParaRPr lang="en-US" dirty="0"/>
+          </a:p>
+        </p:txBody>
+      </p:sp>
+      <p:sp>
+        <p:nvSpPr>
+          <p:cNvPr id="4" name="Slide Number Placeholder 3"/>
+          <p:cNvSpPr>
+            <a:spLocks noGrp="1"/>
+          </p:cNvSpPr>
+          <p:nvPr>
+            <p:ph type="sldNum" sz="quarter" idx="10"/>
+          </p:nvPr>
+        </p:nvSpPr>
+        <p:spPr/>
+        <p:txBody>
+          <a:bodyPr/>
+          <a:lstStyle/>
+          <a:p>
+            <a:fld id="{F7021451-1387-4CA6-816F-3879F97B5CBC}" type="slidenum">
+              <a:rPr lang="en-US"/>
+              <a:t>10</a:t>
+            </a:fld>
+            <a:endParaRPr lang="en-US"/>
+          </a:p>
+        </p:txBody>
+      </p:sp>
+    </p:spTree>
+    <p:extLst>
+      <p:ext uri="{BB962C8B-B14F-4D97-AF65-F5344CB8AC3E}">
+        <p14:creationId xmlns:p14="http://schemas.microsoft.com/office/powerpoint/2010/main" val="1024086991"/>
+      </p:ext>
+    </p:extLst>
+  </p:cSld>
+  <p:clrMapOvr>
+    <a:masterClrMapping/>
+  </p:clrMapOvr>
+</p:notes>
+</file>
+
+<file path=ppt/notesSlides/notesSlide11.xml><?xml version="1.0" encoding="utf-8"?>
+<p:notes xmlns:a="http://schemas.openxmlformats.org/drawingml/2006/main" xmlns:r="http://schemas.openxmlformats.org/officeDocument/2006/relationships" xmlns:p="http://schemas.openxmlformats.org/presentationml/2006/main">
+  <p:cSld>
+    <p:spTree>
+      <p:nvGrpSpPr>
+        <p:cNvPr id="1" name=""/>
+        <p:cNvGrpSpPr/>
+        <p:nvPr/>
+      </p:nvGrpSpPr>
+      <p:grpSpPr>
+        <a:xfrm>
+          <a:off x="0" y="0"/>
+          <a:ext cx="0" cy="0"/>
+          <a:chOff x="0" y="0"/>
+          <a:chExt cx="0" cy="0"/>
+        </a:xfrm>
+      </p:grpSpPr>
+      <p:sp>
+        <p:nvSpPr>
+          <p:cNvPr id="2" name="Slide Image Placeholder 1"/>
+          <p:cNvSpPr>
+            <a:spLocks noGrp="1" noRot="1" noChangeAspect="1"/>
+          </p:cNvSpPr>
+          <p:nvPr>
+            <p:ph type="sldImg"/>
+          </p:nvPr>
+        </p:nvSpPr>
+        <p:spPr/>
+      </p:sp>
+      <p:sp>
+        <p:nvSpPr>
+          <p:cNvPr id="3" name="Notes Placeholder 2"/>
+          <p:cNvSpPr>
+            <a:spLocks noGrp="1"/>
+          </p:cNvSpPr>
+          <p:nvPr>
+            <p:ph type="body" idx="1"/>
+          </p:nvPr>
+        </p:nvSpPr>
+        <p:spPr/>
+        <p:txBody>
+          <a:bodyPr/>
+          <a:lstStyle/>
+          <a:p>
+            <a:r>
+              <a:rPr lang="en-US" dirty="0"/>
+              <a:t>notes:
+(2 min) Locate the audience: anyone running something similar knows
+these components. One login, eight services. The bottom bullet is the
+core tension of this talk: agents with write access on production —
+how do you make that accountable? Answer: the next four cases.</a:t>
+            </a:r>
+            <a:endParaRPr lang="en-US" dirty="0"/>
+          </a:p>
+        </p:txBody>
+      </p:sp>
+      <p:sp>
+        <p:nvSpPr>
+          <p:cNvPr id="4" name="Slide Number Placeholder 3"/>
+          <p:cNvSpPr>
+            <a:spLocks noGrp="1"/>
+          </p:cNvSpPr>
+          <p:nvPr>
+            <p:ph type="sldNum" sz="quarter" idx="10"/>
+          </p:nvPr>
+        </p:nvSpPr>
+        <p:spPr/>
+        <p:txBody>
+          <a:bodyPr/>
+          <a:lstStyle/>
+          <a:p>
+            <a:fld id="{F7021451-1387-4CA6-816F-3879F97B5CBC}" type="slidenum">
+              <a:rPr lang="en-US"/>
+              <a:t>11</a:t>
+            </a:fld>
+            <a:endParaRPr lang="en-US"/>
+          </a:p>
+        </p:txBody>
+      </p:sp>
+    </p:spTree>
+    <p:extLst>
+      <p:ext uri="{BB962C8B-B14F-4D97-AF65-F5344CB8AC3E}">
+        <p14:creationId xmlns:p14="http://schemas.microsoft.com/office/powerpoint/2010/main" val="1024086991"/>
+      </p:ext>
+    </p:extLst>
+  </p:cSld>
+  <p:clrMapOvr>
+    <a:masterClrMapping/>
+  </p:clrMapOvr>
+</p:notes>
+</file>
+
+<file path=ppt/notesSlides/notesSlide12.xml><?xml version="1.0" encoding="utf-8"?>
+<p:notes xmlns:a="http://schemas.openxmlformats.org/drawingml/2006/main" xmlns:r="http://schemas.openxmlformats.org/officeDocument/2006/relationships" xmlns:p="http://schemas.openxmlformats.org/presentationml/2006/main">
+  <p:cSld>
+    <p:spTree>
+      <p:nvGrpSpPr>
+        <p:cNvPr id="1" name=""/>
+        <p:cNvGrpSpPr/>
+        <p:nvPr/>
+      </p:nvGrpSpPr>
+      <p:grpSpPr>
+        <a:xfrm>
+          <a:off x="0" y="0"/>
+          <a:ext cx="0" cy="0"/>
+          <a:chOff x="0" y="0"/>
+          <a:chExt cx="0" cy="0"/>
+        </a:xfrm>
+      </p:grpSpPr>
+      <p:sp>
+        <p:nvSpPr>
+          <p:cNvPr id="2" name="Slide Image Placeholder 1"/>
+          <p:cNvSpPr>
+            <a:spLocks noGrp="1" noRot="1" noChangeAspect="1"/>
+          </p:cNvSpPr>
+          <p:nvPr>
+            <p:ph type="sldImg"/>
+          </p:nvPr>
+        </p:nvSpPr>
+        <p:spPr/>
+      </p:sp>
+      <p:sp>
+        <p:nvSpPr>
+          <p:cNvPr id="3" name="Notes Placeholder 2"/>
+          <p:cNvSpPr>
+            <a:spLocks noGrp="1"/>
+          </p:cNvSpPr>
+          <p:nvPr>
+            <p:ph type="body" idx="1"/>
+          </p:nvPr>
+        </p:nvSpPr>
+        <p:spPr/>
+        <p:txBody>
+          <a:bodyPr/>
+          <a:lstStyle/>
+          <a:p>
+            <a:r>
+              <a:rPr lang="en-US" dirty="0"/>
+              <a:t>notes:
+(3 min) The point: without a spec this is a week of manual work and
+fear. With a spec: one script with built-in guards. Idempotency is
+the acceptance criterion — a second run changes nothing. Story: on
+the first run a guard check fired (one directory matched too much) —
+exactly what guards are for.</a:t>
+            </a:r>
+            <a:endParaRPr lang="en-US" dirty="0"/>
+          </a:p>
+        </p:txBody>
+      </p:sp>
+      <p:sp>
+        <p:nvSpPr>
+          <p:cNvPr id="4" name="Slide Number Placeholder 3"/>
+          <p:cNvSpPr>
+            <a:spLocks noGrp="1"/>
+          </p:cNvSpPr>
+          <p:nvPr>
+            <p:ph type="sldNum" sz="quarter" idx="10"/>
+          </p:nvPr>
+        </p:nvSpPr>
+        <p:spPr/>
+        <p:txBody>
+          <a:bodyPr/>
+          <a:lstStyle/>
+          <a:p>
+            <a:fld id="{F7021451-1387-4CA6-816F-3879F97B5CBC}" type="slidenum">
+              <a:rPr lang="en-US"/>
+              <a:t>12</a:t>
+            </a:fld>
+            <a:endParaRPr lang="en-US"/>
+          </a:p>
+        </p:txBody>
+      </p:sp>
+    </p:spTree>
+    <p:extLst>
+      <p:ext uri="{BB962C8B-B14F-4D97-AF65-F5344CB8AC3E}">
+        <p14:creationId xmlns:p14="http://schemas.microsoft.com/office/powerpoint/2010/main" val="1024086991"/>
+      </p:ext>
+    </p:extLst>
+  </p:cSld>
+  <p:clrMapOvr>
+    <a:masterClrMapping/>
+  </p:clrMapOvr>
+</p:notes>
+</file>
+
+<file path=ppt/notesSlides/notesSlide13.xml><?xml version="1.0" encoding="utf-8"?>
+<p:notes xmlns:a="http://schemas.openxmlformats.org/drawingml/2006/main" xmlns:r="http://schemas.openxmlformats.org/officeDocument/2006/relationships" xmlns:p="http://schemas.openxmlformats.org/presentationml/2006/main">
+  <p:cSld>
+    <p:spTree>
+      <p:nvGrpSpPr>
+        <p:cNvPr id="1" name=""/>
+        <p:cNvGrpSpPr/>
+        <p:nvPr/>
+      </p:nvGrpSpPr>
+      <p:grpSpPr>
+        <a:xfrm>
+          <a:off x="0" y="0"/>
+          <a:ext cx="0" cy="0"/>
+          <a:chOff x="0" y="0"/>
+          <a:chExt cx="0" cy="0"/>
+        </a:xfrm>
+      </p:grpSpPr>
+      <p:sp>
+        <p:nvSpPr>
+          <p:cNvPr id="2" name="Slide Image Placeholder 1"/>
+          <p:cNvSpPr>
+            <a:spLocks noGrp="1" noRot="1" noChangeAspect="1"/>
+          </p:cNvSpPr>
+          <p:nvPr>
+            <p:ph type="sldImg"/>
+          </p:nvPr>
+        </p:nvSpPr>
+        <p:spPr/>
+      </p:sp>
+      <p:sp>
+        <p:nvSpPr>
+          <p:cNvPr id="3" name="Notes Placeholder 2"/>
+          <p:cNvSpPr>
+            <a:spLocks noGrp="1"/>
+          </p:cNvSpPr>
+          <p:nvPr>
+            <p:ph type="body" idx="1"/>
+          </p:nvPr>
+        </p:nvSpPr>
+        <p:spPr/>
+        <p:txBody>
+          <a:bodyPr/>
+          <a:lstStyle/>
+          <a:p>
+            <a:r>
+              <a:rPr lang="en-US" dirty="0"/>
+              <a:t>notes:
 (3 min) Tell it live; everyone knows white pages. Point 1: repo/deploy
 still hung on old domains + placeholder IdP metadata (by design).
 Point 2: TLS termination at the ingress vs. ACS-URL scheme. The agent
@@ -637,7 +919,7 @@
           <a:p>
             <a:fld id="{F7021451-1387-4CA6-816F-3879F97B5CBC}" type="slidenum">
               <a:rPr lang="en-US"/>
-              <a:t>10</a:t>
+              <a:t>13</a:t>
             </a:fld>
             <a:endParaRPr lang="en-US"/>
           </a:p>
@@ -656,7 +938,7 @@
 </p:notes>
 </file>
 
-<file path=ppt/notesSlides/notesSlide11.xml><?xml version="1.0" encoding="utf-8"?>
+<file path=ppt/notesSlides/notesSlide14.xml><?xml version="1.0" encoding="utf-8"?>
 <p:notes xmlns:a="http://schemas.openxmlformats.org/drawingml/2006/main" xmlns:r="http://schemas.openxmlformats.org/officeDocument/2006/relationships" xmlns:p="http://schemas.openxmlformats.org/presentationml/2006/main">
   <p:cSld>
     <p:spTree>
@@ -730,7 +1012,7 @@
           <a:p>
             <a:fld id="{F7021451-1387-4CA6-816F-3879F97B5CBC}" type="slidenum">
               <a:rPr lang="en-US"/>
-              <a:t>11</a:t>
+              <a:t>14</a:t>
             </a:fld>
             <a:endParaRPr lang="en-US"/>
           </a:p>
@@ -749,7 +1031,7 @@
 </p:notes>
 </file>
 
-<file path=ppt/notesSlides/notesSlide12.xml><?xml version="1.0" encoding="utf-8"?>
+<file path=ppt/notesSlides/notesSlide15.xml><?xml version="1.0" encoding="utf-8"?>
 <p:notes xmlns:a="http://schemas.openxmlformats.org/drawingml/2006/main" xmlns:r="http://schemas.openxmlformats.org/officeDocument/2006/relationships" xmlns:p="http://schemas.openxmlformats.org/presentationml/2006/main">
   <p:cSld>
     <p:spTree>
@@ -796,10 +1078,10 @@
             <a:r>
               <a:rPr lang="en-US" dirty="0"/>
               <a:t>notes:
-(3 min) taskfleet: tasks.json + workers.json, isolated worktrees,
-automatic merge only with green gates. This is how the e2e checks for
-all SSO clients were built — logout per client type, session TTL,
-scopes. A human would have spent weeks clicking through this.</a:t>
+(2 min) The tool here is agentflow (next slide). This is how the e2e
+checks for all SSO clients were built — logout per client type,
+session TTL, scopes. A human would have spent weeks clicking through
+this.</a:t>
             </a:r>
             <a:endParaRPr lang="en-US" dirty="0"/>
           </a:p>
@@ -822,7 +1104,7 @@
           <a:p>
             <a:fld id="{F7021451-1387-4CA6-816F-3879F97B5CBC}" type="slidenum">
               <a:rPr lang="en-US"/>
-              <a:t>12</a:t>
+              <a:t>15</a:t>
             </a:fld>
             <a:endParaRPr lang="en-US"/>
           </a:p>
@@ -841,7 +1123,100 @@
 </p:notes>
 </file>
 
-<file path=ppt/notesSlides/notesSlide13.xml><?xml version="1.0" encoding="utf-8"?>
+<file path=ppt/notesSlides/notesSlide16.xml><?xml version="1.0" encoding="utf-8"?>
+<p:notes xmlns:a="http://schemas.openxmlformats.org/drawingml/2006/main" xmlns:r="http://schemas.openxmlformats.org/officeDocument/2006/relationships" xmlns:p="http://schemas.openxmlformats.org/presentationml/2006/main">
+  <p:cSld>
+    <p:spTree>
+      <p:nvGrpSpPr>
+        <p:cNvPr id="1" name=""/>
+        <p:cNvGrpSpPr/>
+        <p:nvPr/>
+      </p:nvGrpSpPr>
+      <p:grpSpPr>
+        <a:xfrm>
+          <a:off x="0" y="0"/>
+          <a:ext cx="0" cy="0"/>
+          <a:chOff x="0" y="0"/>
+          <a:chExt cx="0" cy="0"/>
+        </a:xfrm>
+      </p:grpSpPr>
+      <p:sp>
+        <p:nvSpPr>
+          <p:cNvPr id="2" name="Slide Image Placeholder 1"/>
+          <p:cNvSpPr>
+            <a:spLocks noGrp="1" noRot="1" noChangeAspect="1"/>
+          </p:cNvSpPr>
+          <p:nvPr>
+            <p:ph type="sldImg"/>
+          </p:nvPr>
+        </p:nvSpPr>
+        <p:spPr/>
+      </p:sp>
+      <p:sp>
+        <p:nvSpPr>
+          <p:cNvPr id="3" name="Notes Placeholder 2"/>
+          <p:cNvSpPr>
+            <a:spLocks noGrp="1"/>
+          </p:cNvSpPr>
+          <p:nvPr>
+            <p:ph type="body" idx="1"/>
+          </p:nvPr>
+        </p:nvSpPr>
+        <p:spPr/>
+        <p:txBody>
+          <a:bodyPr/>
+          <a:lstStyle/>
+          <a:p>
+            <a:r>
+              <a:rPr lang="en-US" dirty="0"/>
+              <a:t>notes:
+(2 min) Concrete demo path: af run --dry-run shows the dispatch plan,
+af status is the live board, af cost shows per-worker trust. Failure
+memory is the underrated feature: retries list earlier errors so the
+agent does not repeat them. This is the generalization of Case 4 —
+the same pattern now runs as a product tool.</a:t>
+            </a:r>
+            <a:endParaRPr lang="en-US" dirty="0"/>
+          </a:p>
+        </p:txBody>
+      </p:sp>
+      <p:sp>
+        <p:nvSpPr>
+          <p:cNvPr id="4" name="Slide Number Placeholder 3"/>
+          <p:cNvSpPr>
+            <a:spLocks noGrp="1"/>
+          </p:cNvSpPr>
+          <p:nvPr>
+            <p:ph type="sldNum" sz="quarter" idx="10"/>
+          </p:nvPr>
+        </p:nvSpPr>
+        <p:spPr/>
+        <p:txBody>
+          <a:bodyPr/>
+          <a:lstStyle/>
+          <a:p>
+            <a:fld id="{F7021451-1387-4CA6-816F-3879F97B5CBC}" type="slidenum">
+              <a:rPr lang="en-US"/>
+              <a:t>16</a:t>
+            </a:fld>
+            <a:endParaRPr lang="en-US"/>
+          </a:p>
+        </p:txBody>
+      </p:sp>
+    </p:spTree>
+    <p:extLst>
+      <p:ext uri="{BB962C8B-B14F-4D97-AF65-F5344CB8AC3E}">
+        <p14:creationId xmlns:p14="http://schemas.microsoft.com/office/powerpoint/2010/main" val="1024086991"/>
+      </p:ext>
+    </p:extLst>
+  </p:cSld>
+  <p:clrMapOvr>
+    <a:masterClrMapping/>
+  </p:clrMapOvr>
+</p:notes>
+</file>
+
+<file path=ppt/notesSlides/notesSlide17.xml><?xml version="1.0" encoding="utf-8"?>
 <p:notes xmlns:a="http://schemas.openxmlformats.org/drawingml/2006/main" xmlns:r="http://schemas.openxmlformats.org/officeDocument/2006/relationships" xmlns:p="http://schemas.openxmlformats.org/presentationml/2006/main">
   <p:cSld>
     <p:spTree>
@@ -915,7 +1290,7 @@
           <a:p>
             <a:fld id="{F7021451-1387-4CA6-816F-3879F97B5CBC}" type="slidenum">
               <a:rPr lang="en-US"/>
-              <a:t>13</a:t>
+              <a:t>17</a:t>
             </a:fld>
             <a:endParaRPr lang="en-US"/>
           </a:p>
@@ -934,7 +1309,7 @@
 </p:notes>
 </file>
 
-<file path=ppt/notesSlides/notesSlide14.xml><?xml version="1.0" encoding="utf-8"?>
+<file path=ppt/notesSlides/notesSlide18.xml><?xml version="1.0" encoding="utf-8"?>
 <p:notes xmlns:a="http://schemas.openxmlformats.org/drawingml/2006/main" xmlns:r="http://schemas.openxmlformats.org/officeDocument/2006/relationships" xmlns:p="http://schemas.openxmlformats.org/presentationml/2006/main">
   <p:cSld>
     <p:spTree>
@@ -1007,7 +1382,7 @@
           <a:p>
             <a:fld id="{F7021451-1387-4CA6-816F-3879F97B5CBC}" type="slidenum">
               <a:rPr lang="en-US"/>
-              <a:t>14</a:t>
+              <a:t>18</a:t>
             </a:fld>
             <a:endParaRPr lang="en-US"/>
           </a:p>
@@ -1026,7 +1401,7 @@
 </p:notes>
 </file>
 
-<file path=ppt/notesSlides/notesSlide15.xml><?xml version="1.0" encoding="utf-8"?>
+<file path=ppt/notesSlides/notesSlide19.xml><?xml version="1.0" encoding="utf-8"?>
 <p:notes xmlns:a="http://schemas.openxmlformats.org/drawingml/2006/main" xmlns:r="http://schemas.openxmlformats.org/officeDocument/2006/relationships" xmlns:p="http://schemas.openxmlformats.org/presentationml/2006/main">
   <p:cSld>
     <p:spTree>
@@ -1073,9 +1448,9 @@
             <a:r>
               <a:rPr lang="en-US" dirty="0"/>
               <a:t>notes:
-(30 s) Do not read aloud. Note: the workshop deck (3h version) is
-public — anyone who wants to go deeper can do the exercises
-themselves.</a:t>
+(30 s) Do not read aloud. Everything named here is public and
+tangible: repos, specs, test suites — no slide magic. The workshop
+deck (3h version) is public too — deeper dive = do the exercises.</a:t>
             </a:r>
             <a:endParaRPr lang="en-US" dirty="0"/>
           </a:p>
@@ -1098,99 +1473,7 @@
           <a:p>
             <a:fld id="{F7021451-1387-4CA6-816F-3879F97B5CBC}" type="slidenum">
               <a:rPr lang="en-US"/>
-              <a:t>15</a:t>
-            </a:fld>
-            <a:endParaRPr lang="en-US"/>
-          </a:p>
-        </p:txBody>
-      </p:sp>
-    </p:spTree>
-    <p:extLst>
-      <p:ext uri="{BB962C8B-B14F-4D97-AF65-F5344CB8AC3E}">
-        <p14:creationId xmlns:p14="http://schemas.microsoft.com/office/powerpoint/2010/main" val="1024086991"/>
-      </p:ext>
-    </p:extLst>
-  </p:cSld>
-  <p:clrMapOvr>
-    <a:masterClrMapping/>
-  </p:clrMapOvr>
-</p:notes>
-</file>
-
-<file path=ppt/notesSlides/notesSlide16.xml><?xml version="1.0" encoding="utf-8"?>
-<p:notes xmlns:a="http://schemas.openxmlformats.org/drawingml/2006/main" xmlns:r="http://schemas.openxmlformats.org/officeDocument/2006/relationships" xmlns:p="http://schemas.openxmlformats.org/presentationml/2006/main">
-  <p:cSld>
-    <p:spTree>
-      <p:nvGrpSpPr>
-        <p:cNvPr id="1" name=""/>
-        <p:cNvGrpSpPr/>
-        <p:nvPr/>
-      </p:nvGrpSpPr>
-      <p:grpSpPr>
-        <a:xfrm>
-          <a:off x="0" y="0"/>
-          <a:ext cx="0" cy="0"/>
-          <a:chOff x="0" y="0"/>
-          <a:chExt cx="0" cy="0"/>
-        </a:xfrm>
-      </p:grpSpPr>
-      <p:sp>
-        <p:nvSpPr>
-          <p:cNvPr id="2" name="Slide Image Placeholder 1"/>
-          <p:cNvSpPr>
-            <a:spLocks noGrp="1" noRot="1" noChangeAspect="1"/>
-          </p:cNvSpPr>
-          <p:nvPr>
-            <p:ph type="sldImg"/>
-          </p:nvPr>
-        </p:nvSpPr>
-        <p:spPr/>
-      </p:sp>
-      <p:sp>
-        <p:nvSpPr>
-          <p:cNvPr id="3" name="Notes Placeholder 2"/>
-          <p:cNvSpPr>
-            <a:spLocks noGrp="1"/>
-          </p:cNvSpPr>
-          <p:nvPr>
-            <p:ph type="body" idx="1"/>
-          </p:nvPr>
-        </p:nvSpPr>
-        <p:spPr/>
-        <p:txBody>
-          <a:bodyPr/>
-          <a:lstStyle/>
-          <a:p>
-            <a:r>
-              <a:rPr lang="en-US" dirty="0"/>
-              <a:t>notes:
-(10 min) Q&amp;A. Likely questions: agent permissions/security (→
-contract + plan mode + tests), model choice (→ harness is
-model-agnostic, pi runs with various providers), cost (→ tight specs,
-small orders), getting started (→ AGENTS.md + one boring task).</a:t>
-            </a:r>
-            <a:endParaRPr lang="en-US" dirty="0"/>
-          </a:p>
-        </p:txBody>
-      </p:sp>
-      <p:sp>
-        <p:nvSpPr>
-          <p:cNvPr id="4" name="Slide Number Placeholder 3"/>
-          <p:cNvSpPr>
-            <a:spLocks noGrp="1"/>
-          </p:cNvSpPr>
-          <p:nvPr>
-            <p:ph type="sldNum" sz="quarter" idx="10"/>
-          </p:nvPr>
-        </p:nvSpPr>
-        <p:spPr/>
-        <p:txBody>
-          <a:bodyPr/>
-          <a:lstStyle/>
-          <a:p>
-            <a:fld id="{F7021451-1387-4CA6-816F-3879F97B5CBC}" type="slidenum">
-              <a:rPr lang="en-US"/>
-              <a:t>16</a:t>
+              <a:t>19</a:t>
             </a:fld>
             <a:endParaRPr lang="en-US"/>
           </a:p>
@@ -1302,6 +1585,98 @@
 </p:notes>
 </file>
 
+<file path=ppt/notesSlides/notesSlide20.xml><?xml version="1.0" encoding="utf-8"?>
+<p:notes xmlns:a="http://schemas.openxmlformats.org/drawingml/2006/main" xmlns:r="http://schemas.openxmlformats.org/officeDocument/2006/relationships" xmlns:p="http://schemas.openxmlformats.org/presentationml/2006/main">
+  <p:cSld>
+    <p:spTree>
+      <p:nvGrpSpPr>
+        <p:cNvPr id="1" name=""/>
+        <p:cNvGrpSpPr/>
+        <p:nvPr/>
+      </p:nvGrpSpPr>
+      <p:grpSpPr>
+        <a:xfrm>
+          <a:off x="0" y="0"/>
+          <a:ext cx="0" cy="0"/>
+          <a:chOff x="0" y="0"/>
+          <a:chExt cx="0" cy="0"/>
+        </a:xfrm>
+      </p:grpSpPr>
+      <p:sp>
+        <p:nvSpPr>
+          <p:cNvPr id="2" name="Slide Image Placeholder 1"/>
+          <p:cNvSpPr>
+            <a:spLocks noGrp="1" noRot="1" noChangeAspect="1"/>
+          </p:cNvSpPr>
+          <p:nvPr>
+            <p:ph type="sldImg"/>
+          </p:nvPr>
+        </p:nvSpPr>
+        <p:spPr/>
+      </p:sp>
+      <p:sp>
+        <p:nvSpPr>
+          <p:cNvPr id="3" name="Notes Placeholder 2"/>
+          <p:cNvSpPr>
+            <a:spLocks noGrp="1"/>
+          </p:cNvSpPr>
+          <p:nvPr>
+            <p:ph type="body" idx="1"/>
+          </p:nvPr>
+        </p:nvSpPr>
+        <p:spPr/>
+        <p:txBody>
+          <a:bodyPr/>
+          <a:lstStyle/>
+          <a:p>
+            <a:r>
+              <a:rPr lang="en-US" dirty="0"/>
+              <a:t>notes:
+(10 min) Q&amp;A. Likely questions: agent permissions/security (→
+contract + plan mode + tests), model choice (→ harness is
+model-agnostic, pi runs with various providers), cost (→ tight specs,
+small orders), getting started (→ AGENTS.md + one boring task).</a:t>
+            </a:r>
+            <a:endParaRPr lang="en-US" dirty="0"/>
+          </a:p>
+        </p:txBody>
+      </p:sp>
+      <p:sp>
+        <p:nvSpPr>
+          <p:cNvPr id="4" name="Slide Number Placeholder 3"/>
+          <p:cNvSpPr>
+            <a:spLocks noGrp="1"/>
+          </p:cNvSpPr>
+          <p:nvPr>
+            <p:ph type="sldNum" sz="quarter" idx="10"/>
+          </p:nvPr>
+        </p:nvSpPr>
+        <p:spPr/>
+        <p:txBody>
+          <a:bodyPr/>
+          <a:lstStyle/>
+          <a:p>
+            <a:fld id="{F7021451-1387-4CA6-816F-3879F97B5CBC}" type="slidenum">
+              <a:rPr lang="en-US"/>
+              <a:t>20</a:t>
+            </a:fld>
+            <a:endParaRPr lang="en-US"/>
+          </a:p>
+        </p:txBody>
+      </p:sp>
+    </p:spTree>
+    <p:extLst>
+      <p:ext uri="{BB962C8B-B14F-4D97-AF65-F5344CB8AC3E}">
+        <p14:creationId xmlns:p14="http://schemas.microsoft.com/office/powerpoint/2010/main" val="1024086991"/>
+      </p:ext>
+    </p:extLst>
+  </p:cSld>
+  <p:clrMapOvr>
+    <a:masterClrMapping/>
+  </p:clrMapOvr>
+</p:notes>
+</file>
+
 <file path=ppt/notesSlides/notesSlide3.xml><?xml version="1.0" encoding="utf-8"?>
 <p:notes xmlns:a="http://schemas.openxmlformats.org/drawingml/2006/main" xmlns:r="http://schemas.openxmlformats.org/officeDocument/2006/relationships" xmlns:p="http://schemas.openxmlformats.org/presentationml/2006/main">
   <p:cSld>
@@ -1623,9 +1998,11 @@
             <a:r>
               <a:rPr lang="en-US" dirty="0"/>
               <a:t>notes:
-(2 min) Core slide of the method. All three levels live in the git
-repo, not in heads or chats. Transition: "How do you get from this
-pyramid to a running workflow? → OpenSpec."</a:t>
+(1.5 min) Install is two lines — live-demoable. v1.0 released
+2026-10-01, currently 1.0.2. Ctrl+L is THE shortcut to demo: switch
+model mid-task — cheap model for research, strong model for the fix.
+If someone asks "which key does X": run /hotkeys live. Nix users:
+nix run github:earendil-works/pi/stable.</a:t>
             </a:r>
             <a:endParaRPr lang="en-US" dirty="0"/>
           </a:p>
@@ -1668,6 +2045,193 @@
 </file>
 
 <file path=ppt/notesSlides/notesSlide7.xml><?xml version="1.0" encoding="utf-8"?>
+<p:notes xmlns:a="http://schemas.openxmlformats.org/drawingml/2006/main" xmlns:r="http://schemas.openxmlformats.org/officeDocument/2006/relationships" xmlns:p="http://schemas.openxmlformats.org/presentationml/2006/main">
+  <p:cSld>
+    <p:spTree>
+      <p:nvGrpSpPr>
+        <p:cNvPr id="1" name=""/>
+        <p:cNvGrpSpPr/>
+        <p:nvPr/>
+      </p:nvGrpSpPr>
+      <p:grpSpPr>
+        <a:xfrm>
+          <a:off x="0" y="0"/>
+          <a:ext cx="0" cy="0"/>
+          <a:chOff x="0" y="0"/>
+          <a:chExt cx="0" cy="0"/>
+        </a:xfrm>
+      </p:grpSpPr>
+      <p:sp>
+        <p:nvSpPr>
+          <p:cNvPr id="2" name="Slide Image Placeholder 1"/>
+          <p:cNvSpPr>
+            <a:spLocks noGrp="1" noRot="1" noChangeAspect="1"/>
+          </p:cNvSpPr>
+          <p:nvPr>
+            <p:ph type="sldImg"/>
+          </p:nvPr>
+        </p:nvSpPr>
+        <p:spPr/>
+      </p:sp>
+      <p:sp>
+        <p:nvSpPr>
+          <p:cNvPr id="3" name="Notes Placeholder 2"/>
+          <p:cNvSpPr>
+            <a:spLocks noGrp="1"/>
+          </p:cNvSpPr>
+          <p:nvPr>
+            <p:ph type="body" idx="1"/>
+          </p:nvPr>
+        </p:nvSpPr>
+        <p:spPr/>
+        <p:txBody>
+          <a:bodyPr/>
+          <a:lstStyle/>
+          <a:p>
+            <a:r>
+              <a:rPr lang="en-US" dirty="0"/>
+              <a:t>notes:
+(2 min) This slide earns trust with the ops audience: we TESTED the
+isolation instead of trusting docs. Two headline findings:
+(1) recommended setup = safe against accidents only; (2) documented
+hardening crashes pi. What survives: seccomp/noexec, non-root +
+no-network, gVisor, and the secrets-broker pattern. THREAT_MODEL.md
+has the full matrix with evidence links.</a:t>
+            </a:r>
+            <a:endParaRPr lang="en-US" dirty="0"/>
+          </a:p>
+        </p:txBody>
+      </p:sp>
+      <p:sp>
+        <p:nvSpPr>
+          <p:cNvPr id="4" name="Slide Number Placeholder 3"/>
+          <p:cNvSpPr>
+            <a:spLocks noGrp="1"/>
+          </p:cNvSpPr>
+          <p:nvPr>
+            <p:ph type="sldNum" sz="quarter" idx="10"/>
+          </p:nvPr>
+        </p:nvSpPr>
+        <p:spPr/>
+        <p:txBody>
+          <a:bodyPr/>
+          <a:lstStyle/>
+          <a:p>
+            <a:fld id="{F7021451-1387-4CA6-816F-3879F97B5CBC}" type="slidenum">
+              <a:rPr lang="en-US"/>
+              <a:t>7</a:t>
+            </a:fld>
+            <a:endParaRPr lang="en-US"/>
+          </a:p>
+        </p:txBody>
+      </p:sp>
+    </p:spTree>
+    <p:extLst>
+      <p:ext uri="{BB962C8B-B14F-4D97-AF65-F5344CB8AC3E}">
+        <p14:creationId xmlns:p14="http://schemas.microsoft.com/office/powerpoint/2010/main" val="1024086991"/>
+      </p:ext>
+    </p:extLst>
+  </p:cSld>
+  <p:clrMapOvr>
+    <a:masterClrMapping/>
+  </p:clrMapOvr>
+</p:notes>
+</file>
+
+<file path=ppt/notesSlides/notesSlide8.xml><?xml version="1.0" encoding="utf-8"?>
+<p:notes xmlns:a="http://schemas.openxmlformats.org/drawingml/2006/main" xmlns:r="http://schemas.openxmlformats.org/officeDocument/2006/relationships" xmlns:p="http://schemas.openxmlformats.org/presentationml/2006/main">
+  <p:cSld>
+    <p:spTree>
+      <p:nvGrpSpPr>
+        <p:cNvPr id="1" name=""/>
+        <p:cNvGrpSpPr/>
+        <p:nvPr/>
+      </p:nvGrpSpPr>
+      <p:grpSpPr>
+        <a:xfrm>
+          <a:off x="0" y="0"/>
+          <a:ext cx="0" cy="0"/>
+          <a:chOff x="0" y="0"/>
+          <a:chExt cx="0" cy="0"/>
+        </a:xfrm>
+      </p:grpSpPr>
+      <p:sp>
+        <p:nvSpPr>
+          <p:cNvPr id="2" name="Slide Image Placeholder 1"/>
+          <p:cNvSpPr>
+            <a:spLocks noGrp="1" noRot="1" noChangeAspect="1"/>
+          </p:cNvSpPr>
+          <p:nvPr>
+            <p:ph type="sldImg"/>
+          </p:nvPr>
+        </p:nvSpPr>
+        <p:spPr/>
+      </p:sp>
+      <p:sp>
+        <p:nvSpPr>
+          <p:cNvPr id="3" name="Notes Placeholder 2"/>
+          <p:cNvSpPr>
+            <a:spLocks noGrp="1"/>
+          </p:cNvSpPr>
+          <p:nvPr>
+            <p:ph type="body" idx="1"/>
+          </p:nvPr>
+        </p:nvSpPr>
+        <p:spPr/>
+        <p:txBody>
+          <a:bodyPr/>
+          <a:lstStyle/>
+          <a:p>
+            <a:r>
+              <a:rPr lang="en-US" dirty="0"/>
+              <a:t>notes:
+(3 min) Core slide — read the table column by column with ONE story
+each: column 1 = Case 1 (domain cutover), column 2 = Case 4 (SSO
+suite). Point out: all three levels live in git, not in heads or
+chats. Transition: "How do you get from this pyramid to a running
+workflow? → OpenSpec."</a:t>
+            </a:r>
+            <a:endParaRPr lang="en-US" dirty="0"/>
+          </a:p>
+        </p:txBody>
+      </p:sp>
+      <p:sp>
+        <p:nvSpPr>
+          <p:cNvPr id="4" name="Slide Number Placeholder 3"/>
+          <p:cNvSpPr>
+            <a:spLocks noGrp="1"/>
+          </p:cNvSpPr>
+          <p:nvPr>
+            <p:ph type="sldNum" sz="quarter" idx="10"/>
+          </p:nvPr>
+        </p:nvSpPr>
+        <p:spPr/>
+        <p:txBody>
+          <a:bodyPr/>
+          <a:lstStyle/>
+          <a:p>
+            <a:fld id="{F7021451-1387-4CA6-816F-3879F97B5CBC}" type="slidenum">
+              <a:rPr lang="en-US"/>
+              <a:t>8</a:t>
+            </a:fld>
+            <a:endParaRPr lang="en-US"/>
+          </a:p>
+        </p:txBody>
+      </p:sp>
+    </p:spTree>
+    <p:extLst>
+      <p:ext uri="{BB962C8B-B14F-4D97-AF65-F5344CB8AC3E}">
+        <p14:creationId xmlns:p14="http://schemas.microsoft.com/office/powerpoint/2010/main" val="1024086991"/>
+      </p:ext>
+    </p:extLst>
+  </p:cSld>
+  <p:clrMapOvr>
+    <a:masterClrMapping/>
+  </p:clrMapOvr>
+</p:notes>
+</file>
+
+<file path=ppt/notesSlides/notesSlide9.xml><?xml version="1.0" encoding="utf-8"?>
 <p:notes xmlns:a="http://schemas.openxmlformats.org/drawingml/2006/main" xmlns:r="http://schemas.openxmlformats.org/officeDocument/2006/relationships" xmlns:p="http://schemas.openxmlformats.org/presentationml/2006/main">
   <p:cSld>
     <p:spTree>
@@ -1718,191 +2282,6 @@
 proposal by human or agent, refinement in dialogue, then work through
 tasks. Key point: "archive" updates the specs — that is how the docs
 stay in sync with the system.</a:t>
-            </a:r>
-            <a:endParaRPr lang="en-US" dirty="0"/>
-          </a:p>
-        </p:txBody>
-      </p:sp>
-      <p:sp>
-        <p:nvSpPr>
-          <p:cNvPr id="4" name="Slide Number Placeholder 3"/>
-          <p:cNvSpPr>
-            <a:spLocks noGrp="1"/>
-          </p:cNvSpPr>
-          <p:nvPr>
-            <p:ph type="sldNum" sz="quarter" idx="10"/>
-          </p:nvPr>
-        </p:nvSpPr>
-        <p:spPr/>
-        <p:txBody>
-          <a:bodyPr/>
-          <a:lstStyle/>
-          <a:p>
-            <a:fld id="{F7021451-1387-4CA6-816F-3879F97B5CBC}" type="slidenum">
-              <a:rPr lang="en-US"/>
-              <a:t>7</a:t>
-            </a:fld>
-            <a:endParaRPr lang="en-US"/>
-          </a:p>
-        </p:txBody>
-      </p:sp>
-    </p:spTree>
-    <p:extLst>
-      <p:ext uri="{BB962C8B-B14F-4D97-AF65-F5344CB8AC3E}">
-        <p14:creationId xmlns:p14="http://schemas.microsoft.com/office/powerpoint/2010/main" val="1024086991"/>
-      </p:ext>
-    </p:extLst>
-  </p:cSld>
-  <p:clrMapOvr>
-    <a:masterClrMapping/>
-  </p:clrMapOvr>
-</p:notes>
-</file>
-
-<file path=ppt/notesSlides/notesSlide8.xml><?xml version="1.0" encoding="utf-8"?>
-<p:notes xmlns:a="http://schemas.openxmlformats.org/drawingml/2006/main" xmlns:r="http://schemas.openxmlformats.org/officeDocument/2006/relationships" xmlns:p="http://schemas.openxmlformats.org/presentationml/2006/main">
-  <p:cSld>
-    <p:spTree>
-      <p:nvGrpSpPr>
-        <p:cNvPr id="1" name=""/>
-        <p:cNvGrpSpPr/>
-        <p:nvPr/>
-      </p:nvGrpSpPr>
-      <p:grpSpPr>
-        <a:xfrm>
-          <a:off x="0" y="0"/>
-          <a:ext cx="0" cy="0"/>
-          <a:chOff x="0" y="0"/>
-          <a:chExt cx="0" cy="0"/>
-        </a:xfrm>
-      </p:grpSpPr>
-      <p:sp>
-        <p:nvSpPr>
-          <p:cNvPr id="2" name="Slide Image Placeholder 1"/>
-          <p:cNvSpPr>
-            <a:spLocks noGrp="1" noRot="1" noChangeAspect="1"/>
-          </p:cNvSpPr>
-          <p:nvPr>
-            <p:ph type="sldImg"/>
-          </p:nvPr>
-        </p:nvSpPr>
-        <p:spPr/>
-      </p:sp>
-      <p:sp>
-        <p:nvSpPr>
-          <p:cNvPr id="3" name="Notes Placeholder 2"/>
-          <p:cNvSpPr>
-            <a:spLocks noGrp="1"/>
-          </p:cNvSpPr>
-          <p:nvPr>
-            <p:ph type="body" idx="1"/>
-          </p:nvPr>
-        </p:nvSpPr>
-        <p:spPr/>
-        <p:txBody>
-          <a:bodyPr/>
-          <a:lstStyle/>
-          <a:p>
-            <a:r>
-              <a:rPr lang="en-US" dirty="0"/>
-              <a:t>notes:
-(2 min) Locate the audience: anyone running something similar knows
-these components. One login, eight services. The bottom bullet is the
-core tension of this talk: agents with write access on production —
-how do you make that accountable? Answer: the next four cases.</a:t>
-            </a:r>
-            <a:endParaRPr lang="en-US" dirty="0"/>
-          </a:p>
-        </p:txBody>
-      </p:sp>
-      <p:sp>
-        <p:nvSpPr>
-          <p:cNvPr id="4" name="Slide Number Placeholder 3"/>
-          <p:cNvSpPr>
-            <a:spLocks noGrp="1"/>
-          </p:cNvSpPr>
-          <p:nvPr>
-            <p:ph type="sldNum" sz="quarter" idx="10"/>
-          </p:nvPr>
-        </p:nvSpPr>
-        <p:spPr/>
-        <p:txBody>
-          <a:bodyPr/>
-          <a:lstStyle/>
-          <a:p>
-            <a:fld id="{F7021451-1387-4CA6-816F-3879F97B5CBC}" type="slidenum">
-              <a:rPr lang="en-US"/>
-              <a:t>8</a:t>
-            </a:fld>
-            <a:endParaRPr lang="en-US"/>
-          </a:p>
-        </p:txBody>
-      </p:sp>
-    </p:spTree>
-    <p:extLst>
-      <p:ext uri="{BB962C8B-B14F-4D97-AF65-F5344CB8AC3E}">
-        <p14:creationId xmlns:p14="http://schemas.microsoft.com/office/powerpoint/2010/main" val="1024086991"/>
-      </p:ext>
-    </p:extLst>
-  </p:cSld>
-  <p:clrMapOvr>
-    <a:masterClrMapping/>
-  </p:clrMapOvr>
-</p:notes>
-</file>
-
-<file path=ppt/notesSlides/notesSlide9.xml><?xml version="1.0" encoding="utf-8"?>
-<p:notes xmlns:a="http://schemas.openxmlformats.org/drawingml/2006/main" xmlns:r="http://schemas.openxmlformats.org/officeDocument/2006/relationships" xmlns:p="http://schemas.openxmlformats.org/presentationml/2006/main">
-  <p:cSld>
-    <p:spTree>
-      <p:nvGrpSpPr>
-        <p:cNvPr id="1" name=""/>
-        <p:cNvGrpSpPr/>
-        <p:nvPr/>
-      </p:nvGrpSpPr>
-      <p:grpSpPr>
-        <a:xfrm>
-          <a:off x="0" y="0"/>
-          <a:ext cx="0" cy="0"/>
-          <a:chOff x="0" y="0"/>
-          <a:chExt cx="0" cy="0"/>
-        </a:xfrm>
-      </p:grpSpPr>
-      <p:sp>
-        <p:nvSpPr>
-          <p:cNvPr id="2" name="Slide Image Placeholder 1"/>
-          <p:cNvSpPr>
-            <a:spLocks noGrp="1" noRot="1" noChangeAspect="1"/>
-          </p:cNvSpPr>
-          <p:nvPr>
-            <p:ph type="sldImg"/>
-          </p:nvPr>
-        </p:nvSpPr>
-        <p:spPr/>
-      </p:sp>
-      <p:sp>
-        <p:nvSpPr>
-          <p:cNvPr id="3" name="Notes Placeholder 2"/>
-          <p:cNvSpPr>
-            <a:spLocks noGrp="1"/>
-          </p:cNvSpPr>
-          <p:nvPr>
-            <p:ph type="body" idx="1"/>
-          </p:nvPr>
-        </p:nvSpPr>
-        <p:spPr/>
-        <p:txBody>
-          <a:bodyPr/>
-          <a:lstStyle/>
-          <a:p>
-            <a:r>
-              <a:rPr lang="en-US" dirty="0"/>
-              <a:t>notes:
-(3 min) The point: without a spec this is a week of manual work and
-fear. With a spec: one script with built-in guards. Idempotency is
-the acceptance criterion — a second run changes nothing. Story: on
-the first run a guard check fired (one directory matched too much) —
-exactly what guards are for.</a:t>
             </a:r>
             <a:endParaRPr lang="en-US" dirty="0"/>
           </a:p>
@@ -2563,9 +2942,165 @@
 </p:sld>
 </file>
 
+<file path=ppt/slides/slide17.xml><?xml version="1.0" encoding="utf-8"?>
+<p:sld xmlns:a="http://schemas.openxmlformats.org/drawingml/2006/main" xmlns:r="http://schemas.openxmlformats.org/officeDocument/2006/relationships" xmlns:p="http://schemas.openxmlformats.org/presentationml/2006/main">
+  <p:cSld name="Slide 17">
+    <p:bg>
+      <p:bgPr>
+        <a:blipFill dpi="0" rotWithShape="1">
+          <a:blip r:embed="rId1">
+            <a:lum/>
+          </a:blip>
+          <a:srcRect/>
+          <a:stretch>
+            <a:fillRect/>
+          </a:stretch>
+        </a:blipFill>
+        <a:effectLst/>
+      </p:bgPr>
+    </p:bg>
+    <p:spTree>
+      <p:nvGrpSpPr>
+        <p:cNvPr id="1" name=""/>
+        <p:cNvGrpSpPr/>
+        <p:nvPr/>
+      </p:nvGrpSpPr>
+      <p:grpSpPr>
+        <a:xfrm>
+          <a:off x="0" y="0"/>
+          <a:ext cx="0" cy="0"/>
+          <a:chOff x="0" y="0"/>
+          <a:chExt cx="0" cy="0"/>
+        </a:xfrm>
+      </p:grpSpPr>
+    </p:spTree>
+  </p:cSld>
+  <p:clrMapOvr>
+    <a:masterClrMapping/>
+  </p:clrMapOvr>
+</p:sld>
+</file>
+
+<file path=ppt/slides/slide18.xml><?xml version="1.0" encoding="utf-8"?>
+<p:sld xmlns:a="http://schemas.openxmlformats.org/drawingml/2006/main" xmlns:r="http://schemas.openxmlformats.org/officeDocument/2006/relationships" xmlns:p="http://schemas.openxmlformats.org/presentationml/2006/main">
+  <p:cSld name="Slide 18">
+    <p:bg>
+      <p:bgPr>
+        <a:blipFill dpi="0" rotWithShape="1">
+          <a:blip r:embed="rId1">
+            <a:lum/>
+          </a:blip>
+          <a:srcRect/>
+          <a:stretch>
+            <a:fillRect/>
+          </a:stretch>
+        </a:blipFill>
+        <a:effectLst/>
+      </p:bgPr>
+    </p:bg>
+    <p:spTree>
+      <p:nvGrpSpPr>
+        <p:cNvPr id="1" name=""/>
+        <p:cNvGrpSpPr/>
+        <p:nvPr/>
+      </p:nvGrpSpPr>
+      <p:grpSpPr>
+        <a:xfrm>
+          <a:off x="0" y="0"/>
+          <a:ext cx="0" cy="0"/>
+          <a:chOff x="0" y="0"/>
+          <a:chExt cx="0" cy="0"/>
+        </a:xfrm>
+      </p:grpSpPr>
+    </p:spTree>
+  </p:cSld>
+  <p:clrMapOvr>
+    <a:masterClrMapping/>
+  </p:clrMapOvr>
+</p:sld>
+</file>
+
+<file path=ppt/slides/slide19.xml><?xml version="1.0" encoding="utf-8"?>
+<p:sld xmlns:a="http://schemas.openxmlformats.org/drawingml/2006/main" xmlns:r="http://schemas.openxmlformats.org/officeDocument/2006/relationships" xmlns:p="http://schemas.openxmlformats.org/presentationml/2006/main">
+  <p:cSld name="Slide 19">
+    <p:bg>
+      <p:bgPr>
+        <a:blipFill dpi="0" rotWithShape="1">
+          <a:blip r:embed="rId1">
+            <a:lum/>
+          </a:blip>
+          <a:srcRect/>
+          <a:stretch>
+            <a:fillRect/>
+          </a:stretch>
+        </a:blipFill>
+        <a:effectLst/>
+      </p:bgPr>
+    </p:bg>
+    <p:spTree>
+      <p:nvGrpSpPr>
+        <p:cNvPr id="1" name=""/>
+        <p:cNvGrpSpPr/>
+        <p:nvPr/>
+      </p:nvGrpSpPr>
+      <p:grpSpPr>
+        <a:xfrm>
+          <a:off x="0" y="0"/>
+          <a:ext cx="0" cy="0"/>
+          <a:chOff x="0" y="0"/>
+          <a:chExt cx="0" cy="0"/>
+        </a:xfrm>
+      </p:grpSpPr>
+    </p:spTree>
+  </p:cSld>
+  <p:clrMapOvr>
+    <a:masterClrMapping/>
+  </p:clrMapOvr>
+</p:sld>
+</file>
+
 <file path=ppt/slides/slide2.xml><?xml version="1.0" encoding="utf-8"?>
 <p:sld xmlns:a="http://schemas.openxmlformats.org/drawingml/2006/main" xmlns:r="http://schemas.openxmlformats.org/officeDocument/2006/relationships" xmlns:p="http://schemas.openxmlformats.org/presentationml/2006/main">
   <p:cSld name="Slide 2">
+    <p:bg>
+      <p:bgPr>
+        <a:blipFill dpi="0" rotWithShape="1">
+          <a:blip r:embed="rId1">
+            <a:lum/>
+          </a:blip>
+          <a:srcRect/>
+          <a:stretch>
+            <a:fillRect/>
+          </a:stretch>
+        </a:blipFill>
+        <a:effectLst/>
+      </p:bgPr>
+    </p:bg>
+    <p:spTree>
+      <p:nvGrpSpPr>
+        <p:cNvPr id="1" name=""/>
+        <p:cNvGrpSpPr/>
+        <p:nvPr/>
+      </p:nvGrpSpPr>
+      <p:grpSpPr>
+        <a:xfrm>
+          <a:off x="0" y="0"/>
+          <a:ext cx="0" cy="0"/>
+          <a:chOff x="0" y="0"/>
+          <a:chExt cx="0" cy="0"/>
+        </a:xfrm>
+      </p:grpSpPr>
+    </p:spTree>
+  </p:cSld>
+  <p:clrMapOvr>
+    <a:masterClrMapping/>
+  </p:clrMapOvr>
+</p:sld>
+</file>
+
+<file path=ppt/slides/slide20.xml><?xml version="1.0" encoding="utf-8"?>
+<p:sld xmlns:a="http://schemas.openxmlformats.org/drawingml/2006/main" xmlns:r="http://schemas.openxmlformats.org/officeDocument/2006/relationships" xmlns:p="http://schemas.openxmlformats.org/presentationml/2006/main">
+  <p:cSld name="Slide 20">
     <p:bg>
       <p:bgPr>
         <a:blipFill dpi="0" rotWithShape="1">

</xml_diff>

<commit_message>
GöAID-Talk: deslop — 5x5-style bullets (≤4/slide, keyword phrases), detail moved to speaker notes (20 slides)
</commit_message>
<xml_diff>
--- a/presentation/goaid-agentic-ai-in-practice.pptx
+++ b/presentation/goaid-agentic-ai-in-practice.pptx
@@ -613,11 +613,12 @@
             <a:r>
               <a:rPr lang="en-US" dirty="0"/>
               <a:t>notes:
-(1.5 min) Closes the loop between method and harness: the Spec→
+(1 min) Closes the loop between method and harness: the Spec→
 Contract workflow is wired directly into pi. Fresh session in a repo
 with openspec/ starts already knowing the change state (auto-injected
-context). /opsx-verify before commit is the habit to copy: validate
-+ doctor health sweep. Requires OpenSpec CLI &gt;= 1.9 on PATH.</a:t>
+context, invalidated when the spec tree changes). /opsx-verify
+before commit is the habit to copy: validate + doctor sweep.
+Requires OpenSpec CLI &gt;= 1.9 on PATH.</a:t>
             </a:r>
             <a:endParaRPr lang="en-US" dirty="0"/>
           </a:p>
@@ -706,7 +707,7 @@
             <a:r>
               <a:rPr lang="en-US" dirty="0"/>
               <a:t>notes:
-(2 min) Locate the audience: anyone running something similar knows
+(1.5 min) Locate the audience: anyone running something similar knows
 these components. One login, eight services. The bottom bullet is the
 core tension of this talk: agents with write access on production —
 how do you make that accountable? Answer: the next four cases.</a:t>
@@ -798,11 +799,12 @@
             <a:r>
               <a:rPr lang="en-US" dirty="0"/>
               <a:t>notes:
-(3 min) The point: without a spec this is a week of manual work and
+(2.5 min) The point: without a spec this is a week of manual work and
 fear. With a spec: one script with built-in guards. Idempotency is
 the acceptance criterion — a second run changes nothing. Story: on
 the first run a guard check fired (one directory matched too much) —
-exactly what guards are for.</a:t>
+exactly what guards are for. Also in scope: Keycloak redirects,
+Let's Encrypt wildcard, oauth2-proxy fixes.</a:t>
             </a:r>
             <a:endParaRPr lang="en-US" dirty="0"/>
           </a:p>
@@ -891,12 +893,14 @@
             <a:r>
               <a:rPr lang="en-US" dirty="0"/>
               <a:t>notes:
-(3 min) Tell it live; everyone knows white pages. Point 1: repo/deploy
-still hung on old domains + placeholder IdP metadata (by design).
-Point 2: TLS termination at the ingress vs. ACS-URL scheme. The agent
-needed several probes — but every hypothesis was visible. Afterwards
-each root cause became a probe in the test suite. Key line: "Every bug
-found becomes a test before it comes back."</a:t>
+(2.5 min) Tell it live; everyone knows white pages. SOGo webmail
+after SAML login — three root causes in a row: repo/deploy still on
+old domains + placeholder IdP metadata (by design); TLS termination
+at the ingress vs. ACS-URL scheme. The agent needed several probes —
+but every hypothesis was visible. Second case, same pattern: Stalwart
+XOAUTH2 broke on a dead OIDC issuer inside a directory object.
+Afterwards each root cause became a probe in the test suite. Key
+line: "Every bug found becomes a test before it comes back."</a:t>
             </a:r>
             <a:endParaRPr lang="en-US" dirty="0"/>
           </a:p>
@@ -985,11 +989,11 @@
             <a:r>
               <a:rPr lang="en-US" dirty="0"/>
               <a:t>notes:
-(2 min) This kind of work is boring and important — perfect for
-agents. The human defines: what is "done"? (App exists, sync green,
-no unmanaged manifests left.) The agent works through the list.
-Message to the audience: start with tasks like this, not with
-"write my thesis".</a:t>
+(1.5 min) Tenant mail, LLM, XWiki directories were never under any
+ArgoCD app. This work is tedious and important — perfect for agents.
+The human defines what is "done": app exists, sync green, no
+unmanaged manifests left. The agent works through the list. Message:
+start with tasks like this, not with "write my thesis".</a:t>
             </a:r>
             <a:endParaRPr lang="en-US" dirty="0"/>
           </a:p>
@@ -1078,10 +1082,10 @@
             <a:r>
               <a:rPr lang="en-US" dirty="0"/>
               <a:t>notes:
-(2 min) The tool here is agentflow (next slide). This is how the e2e
-checks for all SSO clients were built — logout per client type,
+(1.5 min) The tool here is agentflow (next slide). This is how the
+e2e checks for all SSO clients were built — logout per client type,
 session TTL, scopes. A human would have spent weeks clicking through
-this.</a:t>
+this. Scalable, cheap, auditable.</a:t>
             </a:r>
             <a:endParaRPr lang="en-US" dirty="0"/>
           </a:p>
@@ -1170,11 +1174,12 @@
             <a:r>
               <a:rPr lang="en-US" dirty="0"/>
               <a:t>notes:
-(2 min) Concrete demo path: af run --dry-run shows the dispatch plan,
-af status is the live board, af cost shows per-worker trust. Failure
-memory is the underrated feature: retries list earlier errors so the
-agent does not repeat them. This is the generalization of Case 4 —
-the same pattern now runs as a product tool.</a:t>
+(1.5 min) Thin by design: drives git and any OpenAI-compatible agent
+CLI — default: pi. 71 tests, no network in CI. Demo path:
+af run --dry-run shows the dispatch plan, af status is the live
+board, af cost shows per-worker trust. Failure memory is underrated:
+retries list earlier errors so the agent does not repeat them.
+github.com/tobias-weiss-ai-xr/agentflow</a:t>
             </a:r>
             <a:endParaRPr lang="en-US" dirty="0"/>
           </a:p>
@@ -1263,11 +1268,11 @@
             <a:r>
               <a:rPr lang="en-US" dirty="0"/>
               <a:t>notes:
-(2 min) The three lessons are deliberately phrased for operations.
-Token case: a tight spec with 5 acceptance criteria beats a
-1000-line prompt. Expectations: from our workshops — people want
-"finished bots" and get a tool with rules. Test first: the SSO suite
-was built exactly this way (59/0/6, every warning discussed).</a:t>
+(1.5 min) Three lessons, phrased for operations. Token case: a tight
+spec with 5 acceptance criteria beats a 1000-line prompt — fewer
+tokens, same quality. Expectations: people want "finished bots" and
+get a tool with rules. Test first: the SSO suite was built exactly
+this way (59/0/6, every warning a documented decision).</a:t>
             </a:r>
             <a:endParaRPr lang="en-US" dirty="0"/>
           </a:p>
@@ -1356,10 +1361,10 @@
             <a:r>
               <a:rPr lang="en-US" dirty="0"/>
               <a:t>notes:
-(2 min) The transfer slide: the audience should be able to do one
+(1.5 min) The transfer slide: the audience should be able to do one
 thing tomorrow. Point 1 costs 20 minutes and changes everything —
 the agent reads the contract on every start. Point 4: experiences /
-spec repo instead of chat history.</a:t>
+spec repo instead of chat history. Not "an agent replaces me".</a:t>
             </a:r>
             <a:endParaRPr lang="en-US" dirty="0"/>
           </a:p>
@@ -1449,8 +1454,9 @@
               <a:rPr lang="en-US" dirty="0"/>
               <a:t>notes:
 (30 s) Do not read aloud. Everything named here is public and
-tangible: repos, specs, test suites — no slide magic. The workshop
-deck (3h version) is public too — deeper dive = do the exercises.</a:t>
+tangible: repos, specs, test suites — no slide magic. GitHub user:
+tobias-weiss-ai-xr. The workshop deck (3h version, IT4Science Days
+2026) is public too — deeper dive = do the exercises.</a:t>
             </a:r>
             <a:endParaRPr lang="en-US" dirty="0"/>
           </a:p>
@@ -1539,7 +1545,7 @@
             <a:r>
               <a:rPr lang="en-US" dirty="0"/>
               <a:t>notes:
-(2 min) Set the context: University of Marburg, DevOps. The suite runs
+(2 min) Context: University of Marburg, DevOps. The suite runs
 productively on our own bare-metal nodes (SCS-K8s), not in a public
 cloud. Two directions of "AI-infused": (a) the suite carries its own
 LLM/K8s resources (k8s/llm), (b) the operation itself is done
@@ -1634,8 +1640,9 @@
               <a:t>notes:
 (10 min) Q&amp;A. Likely questions: agent permissions/security (→
 contract + plan mode + tests), model choice (→ harness is
-model-agnostic, pi runs with various providers), cost (→ tight specs,
-small orders), getting started (→ AGENTS.md + one boring task).</a:t>
+model-agnostic, Ctrl+L, pi runs with various providers), cost (→
+tight specs, small orders), getting started (→ AGENTS.md + one
+boring task).</a:t>
             </a:r>
             <a:endParaRPr lang="en-US" dirty="0"/>
           </a:p>
@@ -1814,10 +1821,10 @@
             <a:r>
               <a:rPr lang="en-US" dirty="0"/>
               <a:t>notes:
-(2 min) Expectation management: agents are not finished bots. A model
-in a chat window cannot touch a file. The agent = model inside a frame
-that gives it tools and rules. Lesson from our courses (participant
-feedback): many expect "ready-made bots" — set that term straight here.</a:t>
+(1.5 min) Expectation management: agents are not finished bots. A
+model in a chat window cannot touch a file. The agent = model inside
+a frame that gives it tools and rules. Lesson from our courses:
+many expect "ready-made bots" — set that term straight here.</a:t>
             </a:r>
             <a:endParaRPr lang="en-US" dirty="0"/>
           </a:p>
@@ -1906,10 +1913,11 @@
             <a:r>
               <a:rPr lang="en-US" dirty="0"/>
               <a:t>notes:
-(2 min) Briefly show or describe pi: opens terminals, reads files,
-runs git, calls MCP tools. Plan mode = consent before any change.
-Important for the ops crowd: the agent has the same rights I have at
-my workstation — hence the contract.</a:t>
+(2 min) Same model, different frame: chat window vs. terminal agent
+with file, git and cluster access. Briefly show or describe pi:
+opens terminals, reads files, runs git, calls MCP tools. Plan mode =
+consent before any change. Ops crowd: the agent has the same rights
+I have at my workstation — hence the contract.</a:t>
             </a:r>
             <a:endParaRPr lang="en-US" dirty="0"/>
           </a:p>
@@ -2002,7 +2010,8 @@
 2026-10-01, currently 1.0.2. Ctrl+L is THE shortcut to demo: switch
 model mid-task — cheap model for research, strong model for the fix.
 If someone asks "which key does X": run /hotkeys live. Nix users:
-nix run github:earendil-works/pi/stable.</a:t>
+nix run github:earendil-works/pi/stable. Radius login and MCP OAuth
+hardening are also in 1.0 — mention if asked.</a:t>
             </a:r>
             <a:endParaRPr lang="en-US" dirty="0"/>
           </a:p>
@@ -2091,12 +2100,14 @@
             <a:r>
               <a:rPr lang="en-US" dirty="0"/>
               <a:t>notes:
-(2 min) This slide earns trust with the ops audience: we TESTED the
-isolation instead of trusting docs. Two headline findings:
-(1) recommended setup = safe against accidents only; (2) documented
-hardening crashes pi. What survives: seccomp/noexec, non-root +
-no-network, gVisor, and the secrets-broker pattern. THREAT_MODEL.md
-has the full matrix with evidence links.</a:t>
+(1.5 min) Earns trust with the ops audience: we TESTED the isolation
+instead of trusting docs. Findings: (1) recommended setup = safe
+against accidents only — a malicious agent exfiltrates the one key
+you pass in; (2) documented hardening crashes pi (--read-only breaks
+the session directory). Survivors: seccomp + noexec (egress cut),
+non-root without network (local models), gVisor, secrets-broker —
+the real key never enters the sandbox.
+github.com/tobias-weiss-ai-xr/pi-sandbox · THREAT_MODEL.md</a:t>
             </a:r>
             <a:endParaRPr lang="en-US" dirty="0"/>
           </a:p>
@@ -2185,11 +2196,11 @@
             <a:r>
               <a:rPr lang="en-US" dirty="0"/>
               <a:t>notes:
-(3 min) Core slide — read the table column by column with ONE story
+(2.5 min) Core slide — read the table column by column with ONE story
 each: column 1 = Case 1 (domain cutover), column 2 = Case 4 (SSO
 suite). Point out: all three levels live in git, not in heads or
-chats. Transition: "How do you get from this pyramid to a running
-workflow? → OpenSpec."</a:t>
+chats. Work becomes repeatable instead of heroic. Transition: "How do
+you get from this pyramid to a running workflow? → OpenSpec."</a:t>
             </a:r>
             <a:endParaRPr lang="en-US" dirty="0"/>
           </a:p>
@@ -2278,10 +2289,10 @@
             <a:r>
               <a:rPr lang="en-US" dirty="0"/>
               <a:t>notes:
-(2 min) OpenSpec CLI: new change, continue, apply, archive. The flow:
-proposal by human or agent, refinement in dialogue, then work through
-tasks. Key point: "archive" updates the specs — that is how the docs
-stay in sync with the system.</a:t>
+(1.5 min) OpenSpec CLI: new change, continue, apply, archive. The
+flow: proposal by human or agent, refinement in dialogue, then work
+through tasks. Key point: "archive" updates the specs — that is how
+the docs stay in sync with the system.</a:t>
             </a:r>
             <a:endParaRPr lang="en-US" dirty="0"/>
           </a:p>

</xml_diff>